<commit_message>
Update carbon black deck: confirmed specs and full contact details
- N550/N660 heating loss set to <= 0.8 % and 45 um sieve residue to
  <= 300 ppm for all grades (TDS table, quality slide, grade slides,
  speaker notes)
- Closing slide now carries the full contact signature
- Non-breaking spaces keep values and units on one line

Co-Authored-By: Claude Opus 5.5 <noreply@anthropic.com>
Claude-Session: https://claude.ai/code/session_01NNdGu1L1tQYbKEuggn2QaY
</commit_message>
<xml_diff>
--- a/Changhong_Carbon_Black_Presentation_EN.pptx
+++ b/Changhong_Carbon_Black_Presentation_EN.pptx
@@ -1326,7 +1326,7 @@
           <a:p>
             <a:r>
               <a:rPr lang="en-US" dirty="0"/>
-              <a:t>N220 is the highest-reinforcing grade in our standard range: ISAF under ASTM, produced at our Fangchenggang base. Iodine number around 121 g/kg, OAN around 114, tint strength around 116. Its core value is abrasion resistance: in passenger, truck and OTR tread compounds it gives a clear gain in tread life over N330. Against the finer N110 and N115, it runs cooler and disperses more easily, so it is the practical balance between wear and processing. Beyond tires, it suits conveyor belt covers, solid tires and premium footwear soles that need high wear resistance and a deep black. Our N220 holds heating loss within 0.8 percent and ash within 0.7 percent, heavy metals are not detected, and every lot comes with a COA. If your tread compound already uses N220, we can send samples for a side-by-side trial.</a:t>
+              <a:t>N220 is the highest-reinforcing grade in our standard range: ISAF under ASTM, produced at our Fangchenggang base. Iodine number around 121 g/kg, OAN around 114, tint strength around 116. Its core value is abrasion resistance: in passenger, truck and OTR tread compounds it gives a clear gain in tread life over N330. Against the finer N110 and N115, it runs cooler and disperses more easily, so it is the practical balance between wear and processing. Beyond tires, it suits conveyor belt covers, solid tires and premium footwear soles that need high wear resistance and a deep black. Our N220 holds heating loss within 0.8 percent, ash within 0.7 percent and 45-micron sieve residue within 300 ppm, heavy metals are not detected, and every lot comes with a COA. If your tread compound already uses N220, we can send samples for a side-by-side trial.</a:t>
             </a:r>
             <a:endParaRPr lang="en-US" dirty="0"/>
           </a:p>
@@ -1414,7 +1414,7 @@
           <a:p>
             <a:r>
               <a:rPr lang="en-US" dirty="0"/>
-              <a:t>N330 is the most widely used reinforcing carbon black in the world, HAF under ASTM, and we produce it at all three of our bases. Iodine number around 82 g/kg, OAN around 102, tint around 104. Its strength is balance: good tensile, tear, abrasion and processing all at once, which is why it runs in tread, carcass, sidewall, conveyor belts, hoses and general rubber goods, the base grade in almost every formulation book. For you that means quick qualification with no reformulation. On quality, heating loss is held within 0.8 percent and ash within 0.7 percent, heavy metals are not detected, and every lot comes with a COA. Three bases mean the most secure supply. We quote FOB or CIF to your port. The most direct way to see lot-to-lot consistency is a trial order.</a:t>
+              <a:t>N330 is the most widely used reinforcing carbon black in the world, HAF under ASTM, and we produce it at all three of our bases. Iodine number around 82 g/kg, OAN around 102, tint around 104. Its strength is balance: good tensile, tear, abrasion and processing all at once, which is why it runs in tread, carcass, sidewall, conveyor belts, hoses and general rubber goods, the base grade in almost every formulation book. For you that means quick qualification with no reformulation. On quality, heating loss is held within 0.8 percent, ash within 0.7 percent and 45-micron sieve residue within 300 ppm, heavy metals are not detected, and every lot comes with a COA. Three bases mean the most secure supply. We quote FOB or CIF to your port. The most direct way to see lot-to-lot consistency is a trial order.</a:t>
             </a:r>
             <a:endParaRPr lang="en-US" dirty="0"/>
           </a:p>
@@ -1502,7 +1502,7 @@
           <a:p>
             <a:r>
               <a:rPr lang="en-US" dirty="0"/>
-              <a:t>N550 is the classic fast-extrusion grade among semi-reinforcing blacks, FEF under ASTM, produced at our Fangchenggang base in Guangxi. Iodine number around 43 g/kg, OAN around 121, the highest structure in our range. The high structure pays off in processing: fast extrusion, low die swell, smooth extrudate and stable dimensions. The coarser particle and low surface area pay off in performance: low heat build-up, low compound viscosity and good flex life, with ash held within 0.5 percent. That is why it goes into tire innerliners, sidewalls and carcass, and into hoses, seals, cable sheathing and anti-vibration parts. It takes high loadings, so compounds stay cost-efficient. Fangchenggang is 35 kilometres from the port, so containers ship by sea straight to Southeast Asia, and ASEAN customers can claim preferential duty. COA with every lot, quoted FOB or CIF.</a:t>
+              <a:t>N550 is the classic fast-extrusion grade among semi-reinforcing blacks, FEF under ASTM, produced at our Fangchenggang base in Guangxi. Iodine number around 43 g/kg, OAN around 121, the highest structure in our range. The high structure pays off in processing: fast extrusion, low die swell, smooth extrudate and stable dimensions. The coarser particle and low surface area pay off in performance: low heat build-up, low compound viscosity and good flex life, with heating loss held within 0.8 percent and ash within 0.5 percent. That is why it goes into tire innerliners, sidewalls and carcass, and into hoses, seals, cable sheathing and anti-vibration parts. It takes high loadings, so compounds stay cost-efficient. Fangchenggang is 35 kilometres from the port, so containers ship by sea straight to Southeast Asia, and ASEAN customers can claim preferential duty. COA with every lot, quoted FOB or CIF.</a:t>
             </a:r>
             <a:endParaRPr lang="en-US" dirty="0"/>
           </a:p>
@@ -2118,7 +2118,7 @@
           <a:p>
             <a:r>
               <a:rPr lang="en-US" dirty="0"/>
-              <a:t>Thank you. I am happy to take your questions, and you can reach me at gaoxz@kygroup.ltd.</a:t>
+              <a:t>Thank you. I am happy to take your questions. My contact details are on this slide; email or WhatsApp both work.</a:t>
             </a:r>
             <a:endParaRPr lang="en-US" dirty="0"/>
           </a:p>
@@ -2734,7 +2734,7 @@
           <a:p>
             <a:r>
               <a:rPr lang="en-US" dirty="0"/>
-              <a:t>Our internal controls are tighter than both the national standard and common industry practice. 45-micron sieve residue is controlled below 300 ppm, against a national limit of 1,000 ppm and an industry norm of 500. Heating loss is controlled at 0.8 percent, against 2.5 percent in the national standard. Our N326 reaches 113 percent tint strength, above the 108 percent industry average, which means a deeper, purer black. Heavy metals are not detected, and every lot ships with a COA.</a:t>
+              <a:t>Our internal controls are tighter than both the national standard and common industry practice. 45-micron sieve residue is controlled within 300 ppm, against a national limit of 1,000 ppm and an industry norm of 500. Heating loss is controlled at 0.8 percent, against 2.5 percent in the national standard. Our N326 reaches 113 percent tint strength, above the 108 percent industry average, which means a deeper, purer black. Heavy metals are not detected, and every lot ships with a COA.</a:t>
             </a:r>
             <a:endParaRPr lang="en-US" dirty="0"/>
           </a:p>
@@ -8959,7 +8959,7 @@
                 <a:ea typeface="Calibri" pitchFamily="34" charset="-122"/>
                 <a:cs typeface="Calibri" pitchFamily="34" charset="-120"/>
               </a:rPr>
-              <a:t>121 ± 6 g/kg</a:t>
+              <a:t>121 ± 6 g/kg</a:t>
             </a:r>
             <a:endParaRPr lang="en-US" sz="1250" dirty="0"/>
           </a:p>
@@ -9060,7 +9060,7 @@
                 <a:ea typeface="Calibri" pitchFamily="34" charset="-122"/>
                 <a:cs typeface="Calibri" pitchFamily="34" charset="-120"/>
               </a:rPr>
-              <a:t>114 ± 6 mL/100 g</a:t>
+              <a:t>114 ± 6 mL/100 g</a:t>
             </a:r>
             <a:endParaRPr lang="en-US" sz="1250" dirty="0"/>
           </a:p>
@@ -9161,7 +9161,7 @@
                 <a:ea typeface="Calibri" pitchFamily="34" charset="-122"/>
                 <a:cs typeface="Calibri" pitchFamily="34" charset="-120"/>
               </a:rPr>
-              <a:t>98 ± 6 mL/100 g</a:t>
+              <a:t>98 ± 6 mL/100 g</a:t>
             </a:r>
             <a:endParaRPr lang="en-US" sz="1250" dirty="0"/>
           </a:p>
@@ -9262,7 +9262,7 @@
                 <a:ea typeface="Calibri" pitchFamily="34" charset="-122"/>
                 <a:cs typeface="Calibri" pitchFamily="34" charset="-120"/>
               </a:rPr>
-              <a:t>116 ± 8 %</a:t>
+              <a:t>116 ± 8 %</a:t>
             </a:r>
             <a:endParaRPr lang="en-US" sz="1250" dirty="0"/>
           </a:p>
@@ -9630,7 +9630,7 @@
                 <a:ea typeface="Calibri" pitchFamily="34" charset="-122"/>
                 <a:cs typeface="Calibri" pitchFamily="34" charset="-120"/>
               </a:rPr>
-              <a:t>Fine 20–25 nm particles with about 45 % more surface area than N330 lift abrasion resistance and tensile strength — longer tread life.</a:t>
+              <a:t>Fine 20–25 nm particles with about 45 % more surface area than N330 lift abrasion resistance and tensile strength — longer tread life.</a:t>
             </a:r>
             <a:endParaRPr lang="en-US" sz="1250" dirty="0"/>
           </a:p>
@@ -9986,7 +9986,7 @@
                 <a:ea typeface="Calibri" pitchFamily="34" charset="-122"/>
                 <a:cs typeface="Calibri" pitchFamily="34" charset="-120"/>
               </a:rPr>
-              <a:t>Tint 116 ± 8 %, heating loss ≤ 0.8 %, ash ≤ 0.7 %, heavy metals not detected — for demanding goods that need wear resistance and a deep black.</a:t>
+              <a:t>Tint 116 ± 8 %, heating loss ≤ 0.8 %, ash ≤ 0.7 %, 45 µm residue ≤ 300 ppm, heavy metals not detected — for goods that need wear resistance and a deep black.</a:t>
             </a:r>
             <a:endParaRPr lang="en-US" sz="1250" dirty="0"/>
           </a:p>
@@ -10675,7 +10675,7 @@
                 <a:ea typeface="Calibri" pitchFamily="34" charset="-122"/>
                 <a:cs typeface="Calibri" pitchFamily="34" charset="-120"/>
               </a:rPr>
-              <a:t>82 ± 6 g/kg</a:t>
+              <a:t>82 ± 6 g/kg</a:t>
             </a:r>
             <a:endParaRPr lang="en-US" sz="1250" dirty="0"/>
           </a:p>
@@ -10776,7 +10776,7 @@
                 <a:ea typeface="Calibri" pitchFamily="34" charset="-122"/>
                 <a:cs typeface="Calibri" pitchFamily="34" charset="-120"/>
               </a:rPr>
-              <a:t>102 ± 6 mL/100 g</a:t>
+              <a:t>102 ± 6 mL/100 g</a:t>
             </a:r>
             <a:endParaRPr lang="en-US" sz="1250" dirty="0"/>
           </a:p>
@@ -10877,7 +10877,7 @@
                 <a:ea typeface="Calibri" pitchFamily="34" charset="-122"/>
                 <a:cs typeface="Calibri" pitchFamily="34" charset="-120"/>
               </a:rPr>
-              <a:t>88 ± 6 mL/100 g</a:t>
+              <a:t>88 ± 6 mL/100 g</a:t>
             </a:r>
             <a:endParaRPr lang="en-US" sz="1250" dirty="0"/>
           </a:p>
@@ -10978,7 +10978,7 @@
                 <a:ea typeface="Calibri" pitchFamily="34" charset="-122"/>
                 <a:cs typeface="Calibri" pitchFamily="34" charset="-120"/>
               </a:rPr>
-              <a:t>104 ± 8 %</a:t>
+              <a:t>104 ± 8 %</a:t>
             </a:r>
             <a:endParaRPr lang="en-US" sz="1250" dirty="0"/>
           </a:p>
@@ -11702,7 +11702,7 @@
                 <a:ea typeface="Calibri" pitchFamily="34" charset="-122"/>
                 <a:cs typeface="Calibri" pitchFamily="34" charset="-120"/>
               </a:rPr>
-              <a:t>Lower heat build-up and quicker dispersion than N220; heating loss ≤ 0.8 %, ash ≤ 0.7 %, heavy metals not detected — fewer grit and contamination issues.</a:t>
+              <a:t>Lower heat build-up and quicker dispersion than N220; heating loss ≤ 0.8 %, ash ≤ 0.7 %, 45 µm residue ≤ 300 ppm, heavy metals not detected — less grit in mixing.</a:t>
             </a:r>
             <a:endParaRPr lang="en-US" sz="1250" dirty="0"/>
           </a:p>
@@ -12760,7 +12760,7 @@
                 <a:ea typeface="Calibri" pitchFamily="34" charset="-122"/>
                 <a:cs typeface="Calibri" pitchFamily="34" charset="-120"/>
               </a:rPr>
-              <a:t>≤ 0.5 %</a:t>
+              <a:t>≤ 0.5 %</a:t>
             </a:r>
             <a:endParaRPr lang="en-US" sz="1250" dirty="0"/>
           </a:p>
@@ -13267,7 +13267,7 @@
                 <a:ea typeface="Arial" pitchFamily="34" charset="-122"/>
                 <a:cs typeface="Arial" pitchFamily="34" charset="-120"/>
               </a:rPr>
-              <a:t>Low heat build-up, low ash</a:t>
+              <a:t>Low heat build-up, low ash and moisture</a:t>
             </a:r>
             <a:endParaRPr lang="en-US" sz="1600" dirty="0"/>
           </a:p>
@@ -13306,7 +13306,7 @@
                 <a:ea typeface="Calibri" pitchFamily="34" charset="-122"/>
                 <a:cs typeface="Calibri" pitchFamily="34" charset="-120"/>
               </a:rPr>
-              <a:t>Coarser particles mean lower compound viscosity, lower hysteresis and good flex-fatigue life; ash ≤ 0.5 %.</a:t>
+              <a:t>Coarser particles mean lower compound viscosity, lower hysteresis and good flex-fatigue life; heating loss ≤ 0.8 %, ash ≤ 0.5 %, 45 µm residue ≤ 300 ppm.</a:t>
             </a:r>
             <a:endParaRPr lang="en-US" sz="1250" dirty="0"/>
           </a:p>
@@ -14322,7 +14322,7 @@
                 <a:ea typeface="Calibri" pitchFamily="34" charset="-122"/>
                 <a:cs typeface="Calibri" pitchFamily="34" charset="-120"/>
               </a:rPr>
-              <a:t>82 ± 6 g/kg</a:t>
+              <a:t>82 ± 6 g/kg</a:t>
             </a:r>
             <a:endParaRPr lang="en-US" sz="1500" dirty="0"/>
           </a:p>
@@ -14427,7 +14427,7 @@
                 <a:ea typeface="Calibri" pitchFamily="34" charset="-122"/>
                 <a:cs typeface="Calibri" pitchFamily="34" charset="-120"/>
               </a:rPr>
-              <a:t>72 ± 6 mL/100 g</a:t>
+              <a:t>72 ± 6 mL/100 g</a:t>
             </a:r>
             <a:endParaRPr lang="en-US" sz="1500" dirty="0"/>
           </a:p>
@@ -14532,7 +14532,7 @@
                 <a:ea typeface="Calibri" pitchFamily="34" charset="-122"/>
                 <a:cs typeface="Calibri" pitchFamily="34" charset="-120"/>
               </a:rPr>
-              <a:t>68 ± 6 mL/100 g</a:t>
+              <a:t>68 ± 6 mL/100 g</a:t>
             </a:r>
             <a:endParaRPr lang="en-US" sz="1500" dirty="0"/>
           </a:p>
@@ -14637,7 +14637,7 @@
                 <a:ea typeface="Calibri" pitchFamily="34" charset="-122"/>
                 <a:cs typeface="Calibri" pitchFamily="34" charset="-120"/>
               </a:rPr>
-              <a:t>111 ± 8 %</a:t>
+              <a:t>111 ± 8 %</a:t>
             </a:r>
             <a:endParaRPr lang="en-US" sz="1500" dirty="0"/>
           </a:p>
@@ -14676,7 +14676,7 @@
                 <a:ea typeface="Calibri" pitchFamily="34" charset="-122"/>
                 <a:cs typeface="Calibri" pitchFamily="34" charset="-120"/>
               </a:rPr>
-              <a:t>113 % tint strength — above the 108 % industry average</a:t>
+              <a:t>113 % tint strength — above the 108 % industry average</a:t>
             </a:r>
             <a:endParaRPr lang="en-US" sz="1400" dirty="0"/>
           </a:p>
@@ -21310,7 +21310,7 @@
                           <a:ea typeface="Calibri" pitchFamily="34" charset="-122"/>
                           <a:cs typeface="Calibri" pitchFamily="34" charset="-120"/>
                         </a:rPr>
-                        <a:t>121 ± 6</a:t>
+                        <a:t>121 ± 6</a:t>
                       </a:r>
                       <a:endParaRPr lang="en-US" sz="1250" dirty="0">
                         <a:latin typeface="Calibri" charset="0"/>
@@ -21378,7 +21378,7 @@
                           <a:ea typeface="Calibri" pitchFamily="34" charset="-122"/>
                           <a:cs typeface="Calibri" pitchFamily="34" charset="-120"/>
                         </a:rPr>
-                        <a:t>82 ± 6</a:t>
+                        <a:t>82 ± 6</a:t>
                       </a:r>
                       <a:endParaRPr lang="en-US" sz="1250" dirty="0">
                         <a:latin typeface="Calibri" charset="0"/>
@@ -21446,7 +21446,7 @@
                           <a:ea typeface="Calibri" pitchFamily="34" charset="-122"/>
                           <a:cs typeface="Calibri" pitchFamily="34" charset="-120"/>
                         </a:rPr>
-                        <a:t>82 ± 6</a:t>
+                        <a:t>82 ± 6</a:t>
                       </a:r>
                       <a:endParaRPr lang="en-US" sz="1250" dirty="0">
                         <a:latin typeface="Calibri" charset="0"/>
@@ -21856,7 +21856,7 @@
                           <a:ea typeface="Calibri" pitchFamily="34" charset="-122"/>
                           <a:cs typeface="Calibri" pitchFamily="34" charset="-120"/>
                         </a:rPr>
-                        <a:t>114 ± 6</a:t>
+                        <a:t>114 ± 6</a:t>
                       </a:r>
                       <a:endParaRPr lang="en-US" sz="1250" dirty="0">
                         <a:latin typeface="Calibri" charset="0"/>
@@ -21924,7 +21924,7 @@
                           <a:ea typeface="Calibri" pitchFamily="34" charset="-122"/>
                           <a:cs typeface="Calibri" pitchFamily="34" charset="-120"/>
                         </a:rPr>
-                        <a:t>102 ± 6</a:t>
+                        <a:t>102 ± 6</a:t>
                       </a:r>
                       <a:endParaRPr lang="en-US" sz="1250" dirty="0">
                         <a:latin typeface="Calibri" charset="0"/>
@@ -21992,7 +21992,7 @@
                           <a:ea typeface="Calibri" pitchFamily="34" charset="-122"/>
                           <a:cs typeface="Calibri" pitchFamily="34" charset="-120"/>
                         </a:rPr>
-                        <a:t>72 ± 6</a:t>
+                        <a:t>72 ± 6</a:t>
                       </a:r>
                       <a:endParaRPr lang="en-US" sz="1250" dirty="0">
                         <a:latin typeface="Calibri" charset="0"/>
@@ -22402,7 +22402,7 @@
                           <a:ea typeface="Calibri" pitchFamily="34" charset="-122"/>
                           <a:cs typeface="Calibri" pitchFamily="34" charset="-120"/>
                         </a:rPr>
-                        <a:t>98 ± 6</a:t>
+                        <a:t>98 ± 6</a:t>
                       </a:r>
                       <a:endParaRPr lang="en-US" sz="1250" dirty="0">
                         <a:latin typeface="Calibri" charset="0"/>
@@ -22470,7 +22470,7 @@
                           <a:ea typeface="Calibri" pitchFamily="34" charset="-122"/>
                           <a:cs typeface="Calibri" pitchFamily="34" charset="-120"/>
                         </a:rPr>
-                        <a:t>88 ± 6</a:t>
+                        <a:t>88 ± 6</a:t>
                       </a:r>
                       <a:endParaRPr lang="en-US" sz="1250" dirty="0">
                         <a:latin typeface="Calibri" charset="0"/>
@@ -22538,7 +22538,7 @@
                           <a:ea typeface="Calibri" pitchFamily="34" charset="-122"/>
                           <a:cs typeface="Calibri" pitchFamily="34" charset="-120"/>
                         </a:rPr>
-                        <a:t>68 ± 6</a:t>
+                        <a:t>68 ± 6</a:t>
                       </a:r>
                       <a:endParaRPr lang="en-US" sz="1250" dirty="0">
                         <a:latin typeface="Calibri" charset="0"/>
@@ -22948,7 +22948,7 @@
                           <a:ea typeface="Calibri" pitchFamily="34" charset="-122"/>
                           <a:cs typeface="Calibri" pitchFamily="34" charset="-120"/>
                         </a:rPr>
-                        <a:t>116 ± 8</a:t>
+                        <a:t>116 ± 8</a:t>
                       </a:r>
                       <a:endParaRPr lang="en-US" sz="1250" dirty="0">
                         <a:latin typeface="Calibri" charset="0"/>
@@ -23016,7 +23016,7 @@
                           <a:ea typeface="Calibri" pitchFamily="34" charset="-122"/>
                           <a:cs typeface="Calibri" pitchFamily="34" charset="-120"/>
                         </a:rPr>
-                        <a:t>104 ± 8</a:t>
+                        <a:t>104 ± 8</a:t>
                       </a:r>
                       <a:endParaRPr lang="en-US" sz="1250" dirty="0">
                         <a:latin typeface="Calibri" charset="0"/>
@@ -23084,7 +23084,7 @@
                           <a:ea typeface="Calibri" pitchFamily="34" charset="-122"/>
                           <a:cs typeface="Calibri" pitchFamily="34" charset="-120"/>
                         </a:rPr>
-                        <a:t>111 ± 8</a:t>
+                        <a:t>111 ± 8</a:t>
                       </a:r>
                       <a:endParaRPr lang="en-US" sz="1250" dirty="0">
                         <a:latin typeface="Calibri" charset="0"/>
@@ -23494,7 +23494,7 @@
                           <a:ea typeface="Calibri" pitchFamily="34" charset="-122"/>
                           <a:cs typeface="Calibri" pitchFamily="34" charset="-120"/>
                         </a:rPr>
-                        <a:t>≤ 0.8</a:t>
+                        <a:t>≤ 0.8</a:t>
                       </a:r>
                       <a:endParaRPr lang="en-US" sz="1250" dirty="0">
                         <a:latin typeface="Calibri" charset="0"/>
@@ -23562,7 +23562,7 @@
                           <a:ea typeface="Calibri" pitchFamily="34" charset="-122"/>
                           <a:cs typeface="Calibri" pitchFamily="34" charset="-120"/>
                         </a:rPr>
-                        <a:t>≤ 0.8</a:t>
+                        <a:t>≤ 0.8</a:t>
                       </a:r>
                       <a:endParaRPr lang="en-US" sz="1250" dirty="0">
                         <a:latin typeface="Calibri" charset="0"/>
@@ -23630,7 +23630,7 @@
                           <a:ea typeface="Calibri" pitchFamily="34" charset="-122"/>
                           <a:cs typeface="Calibri" pitchFamily="34" charset="-120"/>
                         </a:rPr>
-                        <a:t>≤ 0.8</a:t>
+                        <a:t>≤ 0.8</a:t>
                       </a:r>
                       <a:endParaRPr lang="en-US" sz="1250" dirty="0">
                         <a:latin typeface="Calibri" charset="0"/>
@@ -23698,7 +23698,7 @@
                           <a:ea typeface="Calibri" pitchFamily="34" charset="-122"/>
                           <a:cs typeface="Calibri" pitchFamily="34" charset="-120"/>
                         </a:rPr>
-                        <a:t>≤ 1.5</a:t>
+                        <a:t>≤ 0.8</a:t>
                       </a:r>
                       <a:endParaRPr lang="en-US" sz="1250" dirty="0">
                         <a:latin typeface="Calibri" charset="0"/>
@@ -23766,7 +23766,7 @@
                           <a:ea typeface="Calibri" pitchFamily="34" charset="-122"/>
                           <a:cs typeface="Calibri" pitchFamily="34" charset="-120"/>
                         </a:rPr>
-                        <a:t>≤ 1.5</a:t>
+                        <a:t>≤ 0.8</a:t>
                       </a:r>
                       <a:endParaRPr lang="en-US" sz="1250" dirty="0">
                         <a:latin typeface="Calibri" charset="0"/>
@@ -24040,7 +24040,7 @@
                           <a:ea typeface="Calibri" pitchFamily="34" charset="-122"/>
                           <a:cs typeface="Calibri" pitchFamily="34" charset="-120"/>
                         </a:rPr>
-                        <a:t>≤ 0.7</a:t>
+                        <a:t>≤ 0.7</a:t>
                       </a:r>
                       <a:endParaRPr lang="en-US" sz="1250" dirty="0">
                         <a:latin typeface="Calibri" charset="0"/>
@@ -24108,7 +24108,7 @@
                           <a:ea typeface="Calibri" pitchFamily="34" charset="-122"/>
                           <a:cs typeface="Calibri" pitchFamily="34" charset="-120"/>
                         </a:rPr>
-                        <a:t>≤ 0.7</a:t>
+                        <a:t>≤ 0.7</a:t>
                       </a:r>
                       <a:endParaRPr lang="en-US" sz="1250" dirty="0">
                         <a:latin typeface="Calibri" charset="0"/>
@@ -24176,7 +24176,7 @@
                           <a:ea typeface="Calibri" pitchFamily="34" charset="-122"/>
                           <a:cs typeface="Calibri" pitchFamily="34" charset="-120"/>
                         </a:rPr>
-                        <a:t>≤ 0.7</a:t>
+                        <a:t>≤ 0.7</a:t>
                       </a:r>
                       <a:endParaRPr lang="en-US" sz="1250" dirty="0">
                         <a:latin typeface="Calibri" charset="0"/>
@@ -24244,7 +24244,7 @@
                           <a:ea typeface="Calibri" pitchFamily="34" charset="-122"/>
                           <a:cs typeface="Calibri" pitchFamily="34" charset="-120"/>
                         </a:rPr>
-                        <a:t>≤ 0.5</a:t>
+                        <a:t>≤ 0.5</a:t>
                       </a:r>
                       <a:endParaRPr lang="en-US" sz="1250" dirty="0">
                         <a:latin typeface="Calibri" charset="0"/>
@@ -24312,7 +24312,7 @@
                           <a:ea typeface="Calibri" pitchFamily="34" charset="-122"/>
                           <a:cs typeface="Calibri" pitchFamily="34" charset="-120"/>
                         </a:rPr>
-                        <a:t>≤ 0.5</a:t>
+                        <a:t>≤ 0.5</a:t>
                       </a:r>
                       <a:endParaRPr lang="en-US" sz="1250" dirty="0">
                         <a:latin typeface="Calibri" charset="0"/>
@@ -24450,7 +24450,7 @@
                           <a:ea typeface="Calibri" pitchFamily="34" charset="-122"/>
                           <a:cs typeface="Calibri" pitchFamily="34" charset="-120"/>
                         </a:rPr>
-                        <a:t>45 µm sieve residue</a:t>
+                        <a:t>45 µm sieve residue</a:t>
                       </a:r>
                       <a:endParaRPr lang="en-US" sz="1250" dirty="0">
                         <a:latin typeface="Calibri" charset="0"/>
@@ -24586,7 +24586,7 @@
                           <a:ea typeface="Calibri" pitchFamily="34" charset="-122"/>
                           <a:cs typeface="Calibri" pitchFamily="34" charset="-120"/>
                         </a:rPr>
-                        <a:t>≤ 500</a:t>
+                        <a:t>≤ 300</a:t>
                       </a:r>
                       <a:endParaRPr lang="en-US" sz="1250" dirty="0">
                         <a:latin typeface="Calibri" charset="0"/>
@@ -24654,7 +24654,7 @@
                           <a:ea typeface="Calibri" pitchFamily="34" charset="-122"/>
                           <a:cs typeface="Calibri" pitchFamily="34" charset="-120"/>
                         </a:rPr>
-                        <a:t>≤ 500</a:t>
+                        <a:t>≤ 300</a:t>
                       </a:r>
                       <a:endParaRPr lang="en-US" sz="1250" dirty="0">
                         <a:latin typeface="Calibri" charset="0"/>
@@ -24722,7 +24722,7 @@
                           <a:ea typeface="Calibri" pitchFamily="34" charset="-122"/>
                           <a:cs typeface="Calibri" pitchFamily="34" charset="-120"/>
                         </a:rPr>
-                        <a:t>≤ 500</a:t>
+                        <a:t>≤ 300</a:t>
                       </a:r>
                       <a:endParaRPr lang="en-US" sz="1250" dirty="0">
                         <a:latin typeface="Calibri" charset="0"/>
@@ -24790,7 +24790,7 @@
                           <a:ea typeface="Calibri" pitchFamily="34" charset="-122"/>
                           <a:cs typeface="Calibri" pitchFamily="34" charset="-120"/>
                         </a:rPr>
-                        <a:t>≤ 500</a:t>
+                        <a:t>≤ 300</a:t>
                       </a:r>
                       <a:endParaRPr lang="en-US" sz="1250" dirty="0">
                         <a:latin typeface="Calibri" charset="0"/>
@@ -24858,7 +24858,7 @@
                           <a:ea typeface="Calibri" pitchFamily="34" charset="-122"/>
                           <a:cs typeface="Calibri" pitchFamily="34" charset="-120"/>
                         </a:rPr>
-                        <a:t>≤ 500</a:t>
+                        <a:t>≤ 300</a:t>
                       </a:r>
                       <a:endParaRPr lang="en-US" sz="1250" dirty="0">
                         <a:latin typeface="Calibri" charset="0"/>
@@ -25132,7 +25132,7 @@
                           <a:ea typeface="Calibri" pitchFamily="34" charset="-122"/>
                           <a:cs typeface="Calibri" pitchFamily="34" charset="-120"/>
                         </a:rPr>
-                        <a:t>≤ 7.0</a:t>
+                        <a:t>≤ 7.0</a:t>
                       </a:r>
                       <a:endParaRPr lang="en-US" sz="1250" dirty="0">
                         <a:latin typeface="Calibri" charset="0"/>
@@ -25200,7 +25200,7 @@
                           <a:ea typeface="Calibri" pitchFamily="34" charset="-122"/>
                           <a:cs typeface="Calibri" pitchFamily="34" charset="-120"/>
                         </a:rPr>
-                        <a:t>≤ 7.0</a:t>
+                        <a:t>≤ 7.0</a:t>
                       </a:r>
                       <a:endParaRPr lang="en-US" sz="1250" dirty="0">
                         <a:latin typeface="Calibri" charset="0"/>
@@ -25268,7 +25268,7 @@
                           <a:ea typeface="Calibri" pitchFamily="34" charset="-122"/>
                           <a:cs typeface="Calibri" pitchFamily="34" charset="-120"/>
                         </a:rPr>
-                        <a:t>≤ 7.0</a:t>
+                        <a:t>≤ 7.0</a:t>
                       </a:r>
                       <a:endParaRPr lang="en-US" sz="1250" dirty="0">
                         <a:latin typeface="Calibri" charset="0"/>
@@ -25336,7 +25336,7 @@
                           <a:ea typeface="Calibri" pitchFamily="34" charset="-122"/>
                           <a:cs typeface="Calibri" pitchFamily="34" charset="-120"/>
                         </a:rPr>
-                        <a:t>≤ 10.0</a:t>
+                        <a:t>≤ 10.0</a:t>
                       </a:r>
                       <a:endParaRPr lang="en-US" sz="1250" dirty="0">
                         <a:latin typeface="Calibri" charset="0"/>
@@ -25404,7 +25404,7 @@
                           <a:ea typeface="Calibri" pitchFamily="34" charset="-122"/>
                           <a:cs typeface="Calibri" pitchFamily="34" charset="-120"/>
                         </a:rPr>
-                        <a:t>≤ 7.0</a:t>
+                        <a:t>≤ 7.0</a:t>
                       </a:r>
                       <a:endParaRPr lang="en-US" sz="1250" dirty="0">
                         <a:latin typeface="Calibri" charset="0"/>
@@ -25678,7 +25678,7 @@
                           <a:ea typeface="Calibri" pitchFamily="34" charset="-122"/>
                           <a:cs typeface="Calibri" pitchFamily="34" charset="-120"/>
                         </a:rPr>
-                        <a:t>30 ± 10</a:t>
+                        <a:t>30 ± 10</a:t>
                       </a:r>
                       <a:endParaRPr lang="en-US" sz="1250" dirty="0">
                         <a:latin typeface="Calibri" charset="0"/>
@@ -25746,7 +25746,7 @@
                           <a:ea typeface="Calibri" pitchFamily="34" charset="-122"/>
                           <a:cs typeface="Calibri" pitchFamily="34" charset="-120"/>
                         </a:rPr>
-                        <a:t>30 ± 10</a:t>
+                        <a:t>30 ± 10</a:t>
                       </a:r>
                       <a:endParaRPr lang="en-US" sz="1250" dirty="0">
                         <a:latin typeface="Calibri" charset="0"/>
@@ -25814,7 +25814,7 @@
                           <a:ea typeface="Calibri" pitchFamily="34" charset="-122"/>
                           <a:cs typeface="Calibri" pitchFamily="34" charset="-120"/>
                         </a:rPr>
-                        <a:t>30 ± 10</a:t>
+                        <a:t>30 ± 10</a:t>
                       </a:r>
                       <a:endParaRPr lang="en-US" sz="1250" dirty="0">
                         <a:latin typeface="Calibri" charset="0"/>
@@ -26770,7 +26770,7 @@
                           <a:ea typeface="Calibri" pitchFamily="34" charset="-122"/>
                           <a:cs typeface="Calibri" pitchFamily="34" charset="-120"/>
                         </a:rPr>
-                        <a:t>355 ± 40</a:t>
+                        <a:t>355 ± 40</a:t>
                       </a:r>
                       <a:endParaRPr lang="en-US" sz="1250" dirty="0">
                         <a:latin typeface="Calibri" charset="0"/>
@@ -26838,7 +26838,7 @@
                           <a:ea typeface="Calibri" pitchFamily="34" charset="-122"/>
                           <a:cs typeface="Calibri" pitchFamily="34" charset="-120"/>
                         </a:rPr>
-                        <a:t>380 ± 40</a:t>
+                        <a:t>380 ± 40</a:t>
                       </a:r>
                       <a:endParaRPr lang="en-US" sz="1250" dirty="0">
                         <a:latin typeface="Calibri" charset="0"/>
@@ -26906,7 +26906,7 @@
                           <a:ea typeface="Calibri" pitchFamily="34" charset="-122"/>
                           <a:cs typeface="Calibri" pitchFamily="34" charset="-120"/>
                         </a:rPr>
-                        <a:t>455 ± 40</a:t>
+                        <a:t>455 ± 40</a:t>
                       </a:r>
                       <a:endParaRPr lang="en-US" sz="1250" dirty="0">
                         <a:latin typeface="Calibri" charset="0"/>
@@ -27235,7 +27235,7 @@
                 <a:ea typeface="Calibri" pitchFamily="34" charset="-122"/>
                 <a:cs typeface="Calibri" pitchFamily="34" charset="-120"/>
               </a:rPr>
-              <a:t>Source: Zhejiang Changhong Biological Material Co., Ltd. technical data sheet. OAN and COAN in mL/100 g (= 10⁻⁵ m³/kg). Packing: 25 kg bags; 500 kg and 1,000 kg jumbo bags.</a:t>
+              <a:t>Product specifications of Zhejiang Changhong Biological Material Co., Ltd. OAN and COAN in mL/100 g (= 10⁻⁵ m³/kg). Packing: 25 kg bags; 500 kg and 1,000 kg jumbo bags.</a:t>
             </a:r>
             <a:endParaRPr lang="en-US" sz="1150" dirty="0"/>
           </a:p>
@@ -29573,17 +29573,17 @@
         </p:nvSpPr>
         <p:spPr>
           <a:xfrm>
-            <a:off x="3355848" y="3566160"/>
-            <a:ext cx="5486400" cy="1463040"/>
+            <a:off x="1527048" y="3401568"/>
+            <a:ext cx="9144000" cy="1828800"/>
           </a:xfrm>
           <a:prstGeom prst="roundRect">
             <a:avLst>
-              <a:gd name="adj" fmla="val 10000"/>
+              <a:gd name="adj" fmla="val 8000"/>
             </a:avLst>
           </a:prstGeom>
           <a:solidFill>
             <a:srgbClr val="FFFFFF">
-              <a:alpha val="82000"/>
+              <a:alpha val="88000"/>
             </a:srgbClr>
           </a:solidFill>
           <a:ln w="12700">
@@ -29609,8 +29609,8 @@
         </p:nvSpPr>
         <p:spPr>
           <a:xfrm>
-            <a:off x="3538728" y="3657600"/>
-            <a:ext cx="5120640" cy="1280160"/>
+            <a:off x="1828800" y="3538728"/>
+            <a:ext cx="5120640" cy="1554480"/>
           </a:xfrm>
           <a:prstGeom prst="rect">
             <a:avLst/>
@@ -29622,14 +29622,14 @@
           <a:bodyPr wrap="square" lIns="0" tIns="0" rIns="0" bIns="0" rtlCol="0" anchor="ctr"/>
           <a:lstStyle/>
           <a:p>
-            <a:pPr algn="ctr" indent="0" marL="0">
+            <a:pPr algn="l" indent="0" marL="0">
               <a:lnSpc>
-                <a:spcPct val="110000"/>
+                <a:spcPct val="112000"/>
               </a:lnSpc>
               <a:buNone/>
             </a:pPr>
             <a:r>
-              <a:rPr lang="en-US" sz="1800" b="1" dirty="0">
+              <a:rPr lang="en-US" sz="2000" b="1" dirty="0">
                 <a:solidFill>
                   <a:srgbClr val="10233F"/>
                 </a:solidFill>
@@ -29639,12 +29639,12 @@
               </a:rPr>
               <a:t>Xuzhe (Batiste) Gao</a:t>
             </a:r>
-            <a:endParaRPr lang="en-US" sz="1800" dirty="0"/>
-          </a:p>
-          <a:p>
-            <a:pPr algn="ctr" indent="0" marL="0">
+            <a:endParaRPr lang="en-US" sz="2000" dirty="0"/>
+          </a:p>
+          <a:p>
+            <a:pPr algn="l" indent="0" marL="0">
               <a:lnSpc>
-                <a:spcPct val="110000"/>
+                <a:spcPct val="112000"/>
               </a:lnSpc>
               <a:buNone/>
             </a:pPr>
@@ -29657,14 +29657,14 @@
                 <a:ea typeface="Calibri" pitchFamily="34" charset="-122"/>
                 <a:cs typeface="Calibri" pitchFamily="34" charset="-120"/>
               </a:rPr>
-              <a:t>Marketing Division II · Carbon Black</a:t>
-            </a:r>
-            <a:endParaRPr lang="en-US" sz="1800" dirty="0"/>
-          </a:p>
-          <a:p>
-            <a:pPr algn="ctr" indent="0" marL="0">
+              <a:t>Marketing Division II / Carbon Black</a:t>
+            </a:r>
+            <a:endParaRPr lang="en-US" sz="2000" dirty="0"/>
+          </a:p>
+          <a:p>
+            <a:pPr algn="l" indent="0" marL="0">
               <a:lnSpc>
-                <a:spcPct val="110000"/>
+                <a:spcPct val="112000"/>
               </a:lnSpc>
               <a:buNone/>
             </a:pPr>
@@ -29677,29 +29677,222 @@
                 <a:ea typeface="Calibri" pitchFamily="34" charset="-122"/>
                 <a:cs typeface="Calibri" pitchFamily="34" charset="-120"/>
               </a:rPr>
-              <a:t>Zhejiang Changhong Biological Material Co., Ltd.</a:t>
-            </a:r>
-            <a:endParaRPr lang="en-US" sz="1800" dirty="0"/>
-          </a:p>
-          <a:p>
-            <a:pPr algn="ctr" indent="0" marL="0">
+              <a:t>Keyuan Holding Group Co., Ltd.</a:t>
+            </a:r>
+            <a:endParaRPr lang="en-US" sz="2000" dirty="0"/>
+          </a:p>
+          <a:p>
+            <a:pPr algn="l" indent="0" marL="0">
               <a:lnSpc>
-                <a:spcPct val="110000"/>
+                <a:spcPct val="112000"/>
               </a:lnSpc>
               <a:buNone/>
             </a:pPr>
             <a:r>
-              <a:rPr lang="en-US" sz="1300" b="1" dirty="0">
-                <a:solidFill>
-                  <a:srgbClr val="0B4DA2"/>
+              <a:rPr lang="en-US" sz="1250" dirty="0">
+                <a:solidFill>
+                  <a:srgbClr val="1F2937"/>
                 </a:solidFill>
                 <a:latin typeface="Calibri" pitchFamily="34" charset="0"/>
                 <a:ea typeface="Calibri" pitchFamily="34" charset="-122"/>
                 <a:cs typeface="Calibri" pitchFamily="34" charset="-120"/>
               </a:rPr>
-              <a:t>gaoxz@kygroup.ltd   ·   www.changhongpolymer.com</a:t>
-            </a:r>
-            <a:endParaRPr lang="en-US" sz="1800" dirty="0"/>
+              <a:t>ZHEJIANG CHANGHONG BIOLOGICAL MATERIAL CO., LTD.</a:t>
+            </a:r>
+            <a:endParaRPr lang="en-US" sz="2000" dirty="0"/>
+          </a:p>
+        </p:txBody>
+      </p:sp>
+      <p:sp>
+        <p:nvSpPr>
+          <p:cNvPr id="6" name="Shape 4"/>
+          <p:cNvSpPr/>
+          <p:nvPr/>
+        </p:nvSpPr>
+        <p:spPr>
+          <a:xfrm>
+            <a:off x="7132320" y="3657600"/>
+            <a:ext cx="0" cy="1316736"/>
+          </a:xfrm>
+          <a:prstGeom prst="line">
+            <a:avLst/>
+          </a:prstGeom>
+          <a:noFill/>
+          <a:ln w="12700">
+            <a:solidFill>
+              <a:srgbClr val="B9CFEA"/>
+            </a:solidFill>
+            <a:prstDash val="solid"/>
+          </a:ln>
+        </p:spPr>
+      </p:sp>
+      <p:sp>
+        <p:nvSpPr>
+          <p:cNvPr id="7" name="Text 5"/>
+          <p:cNvSpPr txBox="1"/>
+          <p:nvPr/>
+        </p:nvSpPr>
+        <p:spPr>
+          <a:xfrm>
+            <a:off x="7406640" y="3538728"/>
+            <a:ext cx="3108960" cy="1554480"/>
+          </a:xfrm>
+          <a:prstGeom prst="rect">
+            <a:avLst/>
+          </a:prstGeom>
+          <a:noFill/>
+          <a:ln/>
+        </p:spPr>
+        <p:txBody>
+          <a:bodyPr wrap="square" lIns="0" tIns="0" rIns="0" bIns="0" rtlCol="0" anchor="ctr"/>
+          <a:lstStyle/>
+          <a:p>
+            <a:pPr algn="l" indent="0" marL="0">
+              <a:lnSpc>
+                <a:spcPct val="125000"/>
+              </a:lnSpc>
+              <a:buNone/>
+            </a:pPr>
+            <a:r>
+              <a:rPr lang="en-US" sz="1300" b="1" dirty="0">
+                <a:solidFill>
+                  <a:srgbClr val="0B4DA2"/>
+                </a:solidFill>
+                <a:latin typeface="Calibri" pitchFamily="34" charset="0"/>
+                <a:ea typeface="Calibri" pitchFamily="34" charset="-122"/>
+                <a:cs typeface="Calibri" pitchFamily="34" charset="-120"/>
+              </a:rPr>
+              <a:t>Work Email: </a:t>
+            </a:r>
+            <a:pPr algn="l" indent="0" marL="0">
+              <a:lnSpc>
+                <a:spcPct val="125000"/>
+              </a:lnSpc>
+              <a:buNone/>
+            </a:pPr>
+            <a:r>
+              <a:rPr lang="en-US" sz="1300" dirty="0">
+                <a:solidFill>
+                  <a:srgbClr val="1F2937"/>
+                </a:solidFill>
+                <a:latin typeface="Calibri" pitchFamily="34" charset="0"/>
+                <a:ea typeface="Calibri" pitchFamily="34" charset="-122"/>
+                <a:cs typeface="Calibri" pitchFamily="34" charset="-120"/>
+              </a:rPr>
+              <a:t>gaoxz@kygroup.ltd</a:t>
+            </a:r>
+            <a:endParaRPr lang="en-US" sz="1300" dirty="0"/>
+          </a:p>
+          <a:p>
+            <a:pPr algn="l" indent="0" marL="0">
+              <a:lnSpc>
+                <a:spcPct val="125000"/>
+              </a:lnSpc>
+              <a:buNone/>
+            </a:pPr>
+            <a:r>
+              <a:rPr lang="en-US" sz="1300" b="1" dirty="0">
+                <a:solidFill>
+                  <a:srgbClr val="0B4DA2"/>
+                </a:solidFill>
+                <a:latin typeface="Calibri" pitchFamily="34" charset="0"/>
+                <a:ea typeface="Calibri" pitchFamily="34" charset="-122"/>
+                <a:cs typeface="Calibri" pitchFamily="34" charset="-120"/>
+              </a:rPr>
+              <a:t>Personal Email: </a:t>
+            </a:r>
+            <a:pPr algn="l" indent="0" marL="0">
+              <a:lnSpc>
+                <a:spcPct val="125000"/>
+              </a:lnSpc>
+              <a:buNone/>
+            </a:pPr>
+            <a:r>
+              <a:rPr lang="en-US" sz="1300" dirty="0">
+                <a:solidFill>
+                  <a:srgbClr val="1F2937"/>
+                </a:solidFill>
+                <a:latin typeface="Calibri" pitchFamily="34" charset="0"/>
+                <a:ea typeface="Calibri" pitchFamily="34" charset="-122"/>
+                <a:cs typeface="Calibri" pitchFamily="34" charset="-120"/>
+              </a:rPr>
+              <a:t>ish566002@gmail.com</a:t>
+            </a:r>
+            <a:endParaRPr lang="en-US" sz="1300" dirty="0"/>
+          </a:p>
+          <a:p>
+            <a:pPr algn="l" indent="0" marL="0">
+              <a:lnSpc>
+                <a:spcPct val="125000"/>
+              </a:lnSpc>
+              <a:buNone/>
+            </a:pPr>
+            <a:r>
+              <a:rPr lang="en-US" sz="1300" b="1" dirty="0">
+                <a:solidFill>
+                  <a:srgbClr val="0B4DA2"/>
+                </a:solidFill>
+                <a:latin typeface="Calibri" pitchFamily="34" charset="0"/>
+                <a:ea typeface="Calibri" pitchFamily="34" charset="-122"/>
+                <a:cs typeface="Calibri" pitchFamily="34" charset="-120"/>
+              </a:rPr>
+              <a:t>WhatsApp: </a:t>
+            </a:r>
+            <a:pPr algn="l" indent="0" marL="0">
+              <a:lnSpc>
+                <a:spcPct val="125000"/>
+              </a:lnSpc>
+              <a:buNone/>
+            </a:pPr>
+            <a:r>
+              <a:rPr lang="en-US" sz="1300" dirty="0">
+                <a:solidFill>
+                  <a:srgbClr val="1F2937"/>
+                </a:solidFill>
+                <a:latin typeface="Calibri" pitchFamily="34" charset="0"/>
+                <a:ea typeface="Calibri" pitchFamily="34" charset="-122"/>
+                <a:cs typeface="Calibri" pitchFamily="34" charset="-120"/>
+              </a:rPr>
+              <a:t>+44 7536 287291</a:t>
+            </a:r>
+            <a:endParaRPr lang="en-US" sz="1300" dirty="0"/>
+          </a:p>
+          <a:p>
+            <a:pPr algn="l" indent="0" marL="0">
+              <a:lnSpc>
+                <a:spcPct val="125000"/>
+              </a:lnSpc>
+              <a:buNone/>
+            </a:pPr>
+            <a:r>
+              <a:rPr lang="en-US" sz="1300" b="1" dirty="0">
+                <a:solidFill>
+                  <a:srgbClr val="0B4DA2"/>
+                </a:solidFill>
+                <a:latin typeface="Calibri" pitchFamily="34" charset="0"/>
+                <a:ea typeface="Calibri" pitchFamily="34" charset="-122"/>
+                <a:cs typeface="Calibri" pitchFamily="34" charset="-120"/>
+              </a:rPr>
+              <a:t>Mobile: </a:t>
+            </a:r>
+            <a:pPr algn="l" indent="0" marL="0">
+              <a:lnSpc>
+                <a:spcPct val="125000"/>
+              </a:lnSpc>
+              <a:buNone/>
+            </a:pPr>
+            <a:r>
+              <a:rPr lang="en-US" sz="1300" dirty="0">
+                <a:solidFill>
+                  <a:srgbClr val="1F2937"/>
+                </a:solidFill>
+                <a:latin typeface="Calibri" pitchFamily="34" charset="0"/>
+                <a:ea typeface="Calibri" pitchFamily="34" charset="-122"/>
+                <a:cs typeface="Calibri" pitchFamily="34" charset="-120"/>
+              </a:rPr>
+              <a:t>+86 15990233826</a:t>
+            </a:r>
+            <a:endParaRPr lang="en-US" sz="1300" dirty="0"/>
           </a:p>
         </p:txBody>
       </p:sp>
@@ -33267,7 +33460,7 @@
                 <a:ea typeface="Arial" pitchFamily="34" charset="-122"/>
                 <a:cs typeface="Arial" pitchFamily="34" charset="-120"/>
               </a:rPr>
-              <a:t>&lt; 300 ppm</a:t>
+              <a:t>≤ 300 ppm</a:t>
             </a:r>
             <a:endParaRPr lang="en-US" sz="3400" dirty="0"/>
           </a:p>
@@ -33306,7 +33499,7 @@
                 <a:ea typeface="Calibri" pitchFamily="34" charset="-122"/>
                 <a:cs typeface="Calibri" pitchFamily="34" charset="-120"/>
               </a:rPr>
-              <a:t>45 µm sieve residue</a:t>
+              <a:t>45 µm sieve residue</a:t>
             </a:r>
             <a:endParaRPr lang="en-US" sz="1700" dirty="0"/>
           </a:p>
@@ -33387,7 +33580,7 @@
                 <a:ea typeface="Calibri" pitchFamily="34" charset="-122"/>
                 <a:cs typeface="Calibri" pitchFamily="34" charset="-120"/>
               </a:rPr>
-              <a:t>National standard ≤ 1,000 ppm</a:t>
+              <a:t>National standard ≤ 1,000 ppm</a:t>
             </a:r>
             <a:endParaRPr lang="en-US" sz="1400" dirty="0"/>
           </a:p>
@@ -33407,7 +33600,7 @@
                 <a:ea typeface="Calibri" pitchFamily="34" charset="-122"/>
                 <a:cs typeface="Calibri" pitchFamily="34" charset="-120"/>
               </a:rPr>
-              <a:t>Industry ≤ 500 ppm</a:t>
+              <a:t>Industry ≤ 500 ppm</a:t>
             </a:r>
             <a:endParaRPr lang="en-US" sz="1400" dirty="0"/>
           </a:p>
@@ -33482,7 +33675,7 @@
                 <a:ea typeface="Arial" pitchFamily="34" charset="-122"/>
                 <a:cs typeface="Arial" pitchFamily="34" charset="-120"/>
               </a:rPr>
-              <a:t>≤ 0.8 %</a:t>
+              <a:t>≤ 0.8 %</a:t>
             </a:r>
             <a:endParaRPr lang="en-US" sz="3400" dirty="0"/>
           </a:p>
@@ -33602,7 +33795,7 @@
                 <a:ea typeface="Calibri" pitchFamily="34" charset="-122"/>
                 <a:cs typeface="Calibri" pitchFamily="34" charset="-120"/>
               </a:rPr>
-              <a:t>National standard ≤ 2.5 %</a:t>
+              <a:t>National standard ≤ 2.5 %</a:t>
             </a:r>
             <a:endParaRPr lang="en-US" sz="1400" dirty="0"/>
           </a:p>
@@ -33622,7 +33815,7 @@
                 <a:ea typeface="Calibri" pitchFamily="34" charset="-122"/>
                 <a:cs typeface="Calibri" pitchFamily="34" charset="-120"/>
               </a:rPr>
-              <a:t>Industry 2–2.5 %</a:t>
+              <a:t>Industry 2–2.5 %</a:t>
             </a:r>
             <a:endParaRPr lang="en-US" sz="1400" dirty="0"/>
           </a:p>
@@ -33697,7 +33890,7 @@
                 <a:ea typeface="Arial" pitchFamily="34" charset="-122"/>
                 <a:cs typeface="Arial" pitchFamily="34" charset="-120"/>
               </a:rPr>
-              <a:t>113 %</a:t>
+              <a:t>113 %</a:t>
             </a:r>
             <a:endParaRPr lang="en-US" sz="3400" dirty="0"/>
           </a:p>
@@ -33817,7 +34010,7 @@
                 <a:ea typeface="Calibri" pitchFamily="34" charset="-122"/>
                 <a:cs typeface="Calibri" pitchFamily="34" charset="-120"/>
               </a:rPr>
-              <a:t>Industry average 108 %</a:t>
+              <a:t>Industry average 108 %</a:t>
             </a:r>
             <a:endParaRPr lang="en-US" sz="1400" dirty="0"/>
           </a:p>

</xml_diff>